<commit_message>
로컬 LLM v3 적용: 6개 지역 학습(982/192), 평가 48/48(v2도 48/48, 중앙 39초), 앱 경로 7곳 검증 위반 0
- scripts/llm/README.md: 재학습 v3 절(자료·학습·평가·판정·앱 점검·한계)
- 발표자료 LLM 장과 한 장 요약에 결과 반영(PPTX·PDF)
- 매뉴얼·USAGE: 요약 모델 이름 v3, 매뉴얼 PDF 다시 만들기
- LIMITATIONS: v2·v3 통과율 차이 없음, 문장 품질은 재지 않음

Co-Authored-By: Claude Opus 5.5 <noreply@anthropic.com>
Claude-Session: https://claude.ai/code/session_01FHHEuZJMkY1PRrj63r7SZr
</commit_message>
<xml_diff>
--- a/docs/presentation/Carbon-Urban-DSS-업계활용-사용성개선.pptx
+++ b/docs/presentation/Carbon-Urban-DSS-업계활용-사용성개선.pptx
@@ -8918,7 +8918,7 @@
                           <a:ea typeface="Malgun Gothic" pitchFamily="34" charset="-122"/>
                           <a:cs typeface="Malgun Gothic" pitchFamily="34" charset="-120"/>
                         </a:rPr>
-                        <a:t>v2 (현재까지)</a:t>
+                        <a:t>v2 (이전)</a:t>
                       </a:r>
                       <a:endParaRPr lang="en-US" sz="1200" dirty="0">
                         <a:latin typeface="Malgun Gothic" charset="0"/>
@@ -9674,7 +9674,7 @@
                           <a:ea typeface="Malgun Gothic" pitchFamily="34" charset="-122"/>
                           <a:cs typeface="Malgun Gothic" pitchFamily="34" charset="-120"/>
                         </a:rPr>
-                        <a:t>평가 (같은 표본)</a:t>
+                        <a:t>평가 (같은 48개 표본, 6개 지역)</a:t>
                       </a:r>
                       <a:endParaRPr lang="en-US" sz="1200" dirty="0">
                         <a:latin typeface="Malgun Gothic" charset="0"/>
@@ -9742,7 +9742,7 @@
                           <a:ea typeface="Malgun Gothic" pitchFamily="34" charset="-122"/>
                           <a:cs typeface="Malgun Gothic" pitchFamily="34" charset="-120"/>
                         </a:rPr>
-                        <a:t>평가 진행 중</a:t>
+                        <a:t>48/48 통과 · 중앙 40초</a:t>
                       </a:r>
                       <a:endParaRPr lang="en-US" sz="1200" dirty="0">
                         <a:latin typeface="Malgun Gothic" charset="0"/>
@@ -9810,7 +9810,7 @@
                           <a:ea typeface="Malgun Gothic" pitchFamily="34" charset="-122"/>
                           <a:cs typeface="Malgun Gothic" pitchFamily="34" charset="-120"/>
                         </a:rPr>
-                        <a:t>학습 진행 중</a:t>
+                        <a:t>48/48 통과 · 중앙 39초</a:t>
                       </a:r>
                       <a:endParaRPr lang="en-US" sz="1200" dirty="0">
                         <a:latin typeface="Malgun Gothic" charset="0"/>
@@ -10016,7 +10016,7 @@
                           <a:ea typeface="Malgun Gothic" pitchFamily="34" charset="-122"/>
                           <a:cs typeface="Malgun Gothic" pitchFamily="34" charset="-120"/>
                         </a:rPr>
-                        <a:t>평가 뒤 결정(조건 충족 시 v3)</a:t>
+                        <a:t>carbon-area-narrator-v3 (10/10 적용)</a:t>
                       </a:r>
                       <a:endParaRPr lang="en-US" sz="1200" dirty="0">
                         <a:latin typeface="Malgun Gothic" charset="0"/>
@@ -10080,8 +10080,8 @@
         </p:nvSpPr>
         <p:spPr>
           <a:xfrm>
-            <a:off x="548640" y="4663440"/>
-            <a:ext cx="11109960" cy="1463040"/>
+            <a:off x="548640" y="4526280"/>
+            <a:ext cx="11109960" cy="1691640"/>
           </a:xfrm>
           <a:prstGeom prst="rect">
             <a:avLst/>
@@ -10109,7 +10109,7 @@
                 <a:ea typeface="Malgun Gothic" pitchFamily="34" charset="-122"/>
                 <a:cs typeface="Malgun Gothic" pitchFamily="34" charset="-120"/>
               </a:rPr>
-              <a:t>QLoRA (Qwen2.5-1.5B, RTX 2060 6GB, 4-bit) → 병합 → GGUF q8_0 → Ollama 등록</a:t>
+              <a:t>QLoRA (Qwen2.5-1.5B, RTX 2060 6GB, 4-bit) 1.83 epoch · 114스텝 · 5시간 11분, 평가 손실 0.0054 → 병합 → GGUF q8_0 → Ollama 등록</a:t>
             </a:r>
             <a:endParaRPr lang="en-US" sz="1200" dirty="0"/>
           </a:p>
@@ -10130,7 +10130,28 @@
                 <a:ea typeface="Malgun Gothic" pitchFamily="34" charset="-122"/>
                 <a:cs typeface="Malgun Gothic" pitchFamily="34" charset="-120"/>
               </a:rPr>
-              <a:t>바꾸는 조건: 같은 평가 표본에서 통과율이 v2 이상, 오류 수가 v2 이하, 중앙 응답 150초 이하</a:t>
+              <a:t>바꾸는 조건: 같은 평가 표본에서 통과율 v2 이상, 오류 수 v2 이하, 중앙 응답 150초 이하 → 충족해 10/10 앱에 적용</a:t>
+            </a:r>
+            <a:endParaRPr lang="en-US" sz="1200" dirty="0"/>
+          </a:p>
+          <a:p>
+            <a:pPr marL="342900" indent="-342900">
+              <a:spcAft>
+                <a:spcPts val="500"/>
+              </a:spcAft>
+              <a:buSzPct val="100000"/>
+              <a:buChar char="•"/>
+            </a:pPr>
+            <a:r>
+              <a:rPr lang="en-US" sz="1200" dirty="0">
+                <a:solidFill>
+                  <a:srgbClr val="1C2622"/>
+                </a:solidFill>
+                <a:latin typeface="Malgun Gothic" pitchFamily="34" charset="0"/>
+                <a:ea typeface="Malgun Gothic" pitchFamily="34" charset="-122"/>
+                <a:cs typeface="Malgun Gothic" pitchFamily="34" charset="-120"/>
+              </a:rPr>
+              <a:t>이 표본에서는 v2도 48/48이라 통과율 차이는 없음 (v3는 나빠지지 않고 조금 빠름). 문장 품질은 이 평가가 재지 않음</a:t>
             </a:r>
             <a:endParaRPr lang="en-US" sz="1200" dirty="0"/>
           </a:p>
@@ -12053,7 +12074,7 @@
                 <a:ea typeface="Malgun Gothic" pitchFamily="34" charset="-122"/>
                 <a:cs typeface="Malgun Gothic" pitchFamily="34" charset="-120"/>
               </a:rPr>
-              <a:t>백엔드 317 통과 (기존 스텁 실패 28 동일) · 프런트 154 통과 · 빌드 성공 · 연도 부분집합 60/60 동일 · 로컬 LLM v3 학습 진행 중</a:t>
+              <a:t>백엔드 317 통과 (기존 스텁 실패 28 동일) · 프런트 154 통과 · 빌드 성공 · 연도 부분집합 60/60 동일 · 로컬 LLM v3 48/48 통과 → 적용</a:t>
             </a:r>
             <a:endParaRPr lang="en-US" sz="1250" dirty="0"/>
           </a:p>

</xml_diff>